<commit_message>
cleanup and processing of new serum file
</commit_message>
<xml_diff>
--- a/turboid_analysis_012723.pptx
+++ b/turboid_analysis_012723.pptx
@@ -5,7 +5,7 @@
     <p:sldMasterId id="2147483712" r:id="rId1"/>
   </p:sldMasterIdLst>
   <p:notesMasterIdLst>
-    <p:notesMasterId r:id="rId17"/>
+    <p:notesMasterId r:id="rId18"/>
   </p:notesMasterIdLst>
   <p:sldIdLst>
     <p:sldId id="256" r:id="rId2"/>
@@ -22,7 +22,8 @@
     <p:sldId id="287" r:id="rId13"/>
     <p:sldId id="288" r:id="rId14"/>
     <p:sldId id="290" r:id="rId15"/>
-    <p:sldId id="289" r:id="rId16"/>
+    <p:sldId id="295" r:id="rId16"/>
+    <p:sldId id="289" r:id="rId17"/>
   </p:sldIdLst>
   <p:sldSz cx="12192000" cy="6858000"/>
   <p:notesSz cx="6858000" cy="9144000"/>
@@ -4148,7 +4149,7 @@
           <a:p>
             <a:fld id="{5D91BF4D-3201-F745-B932-E7F786B71255}" type="datetimeFigureOut">
               <a:rPr lang="en-US" smtClean="0"/>
-              <a:t>1/27/23</a:t>
+              <a:t>3/2/23</a:t>
             </a:fld>
             <a:endParaRPr lang="en-US"/>
           </a:p>
@@ -5067,6 +5068,153 @@
 </p:notes>
 </file>
 
+<file path=ppt/notesSlides/notesSlide13.xml><?xml version="1.0" encoding="utf-8"?>
+<p:notes xmlns:a="http://schemas.openxmlformats.org/drawingml/2006/main" xmlns:r="http://schemas.openxmlformats.org/officeDocument/2006/relationships" xmlns:p="http://schemas.openxmlformats.org/presentationml/2006/main">
+  <p:cSld>
+    <p:spTree>
+      <p:nvGrpSpPr>
+        <p:cNvPr id="1" name=""/>
+        <p:cNvGrpSpPr/>
+        <p:nvPr/>
+      </p:nvGrpSpPr>
+      <p:grpSpPr>
+        <a:xfrm>
+          <a:off x="0" y="0"/>
+          <a:ext cx="0" cy="0"/>
+          <a:chOff x="0" y="0"/>
+          <a:chExt cx="0" cy="0"/>
+        </a:xfrm>
+      </p:grpSpPr>
+      <p:sp>
+        <p:nvSpPr>
+          <p:cNvPr id="2" name="Slide Image Placeholder 1"/>
+          <p:cNvSpPr>
+            <a:spLocks noGrp="1" noRot="1" noChangeAspect="1"/>
+          </p:cNvSpPr>
+          <p:nvPr>
+            <p:ph type="sldImg"/>
+          </p:nvPr>
+        </p:nvSpPr>
+        <p:spPr/>
+      </p:sp>
+      <p:sp>
+        <p:nvSpPr>
+          <p:cNvPr id="3" name="Notes Placeholder 2"/>
+          <p:cNvSpPr>
+            <a:spLocks noGrp="1"/>
+          </p:cNvSpPr>
+          <p:nvPr>
+            <p:ph type="body" idx="1"/>
+          </p:nvPr>
+        </p:nvSpPr>
+        <p:spPr/>
+        <p:txBody>
+          <a:bodyPr/>
+          <a:lstStyle/>
+          <a:p>
+            <a:r>
+              <a:rPr lang="en-US" dirty="0"/>
+              <a:t>From question </a:t>
+            </a:r>
+          </a:p>
+        </p:txBody>
+      </p:sp>
+      <p:sp>
+        <p:nvSpPr>
+          <p:cNvPr id="4" name="Slide Number Placeholder 3"/>
+          <p:cNvSpPr>
+            <a:spLocks noGrp="1"/>
+          </p:cNvSpPr>
+          <p:nvPr>
+            <p:ph type="sldNum" sz="quarter" idx="5"/>
+          </p:nvPr>
+        </p:nvSpPr>
+        <p:spPr/>
+        <p:txBody>
+          <a:bodyPr/>
+          <a:lstStyle/>
+          <a:p>
+            <a:pPr marL="0" marR="0" lvl="0" indent="0" algn="r" defTabSz="914400" rtl="0" eaLnBrk="1" fontAlgn="auto" latinLnBrk="0" hangingPunct="1">
+              <a:lnSpc>
+                <a:spcPct val="100000"/>
+              </a:lnSpc>
+              <a:spcBef>
+                <a:spcPts val="0"/>
+              </a:spcBef>
+              <a:spcAft>
+                <a:spcPts val="0"/>
+              </a:spcAft>
+              <a:buClrTx/>
+              <a:buSzTx/>
+              <a:buFontTx/>
+              <a:buNone/>
+              <a:tabLst/>
+              <a:defRPr/>
+            </a:pPr>
+            <a:fld id="{5E3C3097-339F-D341-9AE2-47DB3DE0E34B}" type="slidenum">
+              <a:rPr kumimoji="0" lang="en-US" sz="1200" b="0" i="0" u="none" strike="noStrike" kern="1200" cap="none" spc="0" normalizeH="0" baseline="0" noProof="0" smtClean="0">
+                <a:ln>
+                  <a:noFill/>
+                </a:ln>
+                <a:solidFill>
+                  <a:prstClr val="black"/>
+                </a:solidFill>
+                <a:effectLst/>
+                <a:uLnTx/>
+                <a:uFillTx/>
+                <a:latin typeface="Calibri" panose="020F0502020204030204"/>
+                <a:ea typeface="+mn-ea"/>
+                <a:cs typeface="+mn-cs"/>
+              </a:rPr>
+              <a:pPr marL="0" marR="0" lvl="0" indent="0" algn="r" defTabSz="914400" rtl="0" eaLnBrk="1" fontAlgn="auto" latinLnBrk="0" hangingPunct="1">
+                <a:lnSpc>
+                  <a:spcPct val="100000"/>
+                </a:lnSpc>
+                <a:spcBef>
+                  <a:spcPts val="0"/>
+                </a:spcBef>
+                <a:spcAft>
+                  <a:spcPts val="0"/>
+                </a:spcAft>
+                <a:buClrTx/>
+                <a:buSzTx/>
+                <a:buFontTx/>
+                <a:buNone/>
+                <a:tabLst/>
+                <a:defRPr/>
+              </a:pPr>
+              <a:t>14</a:t>
+            </a:fld>
+            <a:endParaRPr kumimoji="0" lang="en-US" sz="1200" b="0" i="0" u="none" strike="noStrike" kern="1200" cap="none" spc="0" normalizeH="0" baseline="0" noProof="0">
+              <a:ln>
+                <a:noFill/>
+              </a:ln>
+              <a:solidFill>
+                <a:prstClr val="black"/>
+              </a:solidFill>
+              <a:effectLst/>
+              <a:uLnTx/>
+              <a:uFillTx/>
+              <a:latin typeface="Calibri" panose="020F0502020204030204"/>
+              <a:ea typeface="+mn-ea"/>
+              <a:cs typeface="+mn-cs"/>
+            </a:endParaRPr>
+          </a:p>
+        </p:txBody>
+      </p:sp>
+    </p:spTree>
+    <p:extLst>
+      <p:ext uri="{BB962C8B-B14F-4D97-AF65-F5344CB8AC3E}">
+        <p14:creationId xmlns:p14="http://schemas.microsoft.com/office/powerpoint/2010/main" val="1141709378"/>
+      </p:ext>
+    </p:extLst>
+  </p:cSld>
+  <p:clrMapOvr>
+    <a:masterClrMapping/>
+  </p:clrMapOvr>
+</p:notes>
+</file>
+
 <file path=ppt/notesSlides/notesSlide2.xml><?xml version="1.0" encoding="utf-8"?>
 <p:notes xmlns:a="http://schemas.openxmlformats.org/drawingml/2006/main" xmlns:r="http://schemas.openxmlformats.org/officeDocument/2006/relationships" xmlns:p="http://schemas.openxmlformats.org/presentationml/2006/main">
   <p:cSld>
@@ -6153,7 +6301,7 @@
           <a:p>
             <a:fld id="{4D82D62B-C5BC-9A48-B649-B612C2626DF0}" type="datetime2">
               <a:rPr lang="en-US" smtClean="0"/>
-              <a:t>Friday, January 27, 2023</a:t>
+              <a:t>Thursday, March 2, 2023</a:t>
             </a:fld>
             <a:endParaRPr lang="en-US" dirty="0"/>
           </a:p>
@@ -6356,7 +6504,7 @@
           <a:p>
             <a:fld id="{8C7BF22D-4351-7443-9203-BE328953BFC7}" type="datetime2">
               <a:rPr lang="en-US" smtClean="0"/>
-              <a:t>Friday, January 27, 2023</a:t>
+              <a:t>Thursday, March 2, 2023</a:t>
             </a:fld>
             <a:endParaRPr lang="en-US"/>
           </a:p>
@@ -6569,7 +6717,7 @@
           <a:p>
             <a:fld id="{9FDF6349-9520-004C-B410-2193F9372E49}" type="datetime2">
               <a:rPr lang="en-US" smtClean="0"/>
-              <a:t>Friday, January 27, 2023</a:t>
+              <a:t>Thursday, March 2, 2023</a:t>
             </a:fld>
             <a:endParaRPr lang="en-US"/>
           </a:p>
@@ -6771,7 +6919,7 @@
           <a:p>
             <a:fld id="{E9A10DC3-F6B5-014A-A9AD-0D47C6506BAB}" type="datetime2">
               <a:rPr lang="en-US" smtClean="0"/>
-              <a:t>Friday, January 27, 2023</a:t>
+              <a:t>Thursday, March 2, 2023</a:t>
             </a:fld>
             <a:endParaRPr lang="en-US" dirty="0"/>
           </a:p>
@@ -7050,7 +7198,7 @@
           <a:p>
             <a:fld id="{A049C287-8CF4-DC48-88B8-6E35669697EC}" type="datetime2">
               <a:rPr lang="en-US" smtClean="0"/>
-              <a:t>Friday, January 27, 2023</a:t>
+              <a:t>Thursday, March 2, 2023</a:t>
             </a:fld>
             <a:endParaRPr lang="en-US"/>
           </a:p>
@@ -7310,7 +7458,7 @@
           <a:p>
             <a:fld id="{ADEB5C39-7764-3744-BF89-1BA0C95D9B94}" type="datetime2">
               <a:rPr lang="en-US" smtClean="0"/>
-              <a:t>Friday, January 27, 2023</a:t>
+              <a:t>Thursday, March 2, 2023</a:t>
             </a:fld>
             <a:endParaRPr lang="en-US"/>
           </a:p>
@@ -7726,7 +7874,7 @@
           <a:p>
             <a:fld id="{4BAB7099-C23E-1745-AF03-0B0C40F6AA6C}" type="datetime2">
               <a:rPr lang="en-US" smtClean="0"/>
-              <a:t>Friday, January 27, 2023</a:t>
+              <a:t>Thursday, March 2, 2023</a:t>
             </a:fld>
             <a:endParaRPr lang="en-US"/>
           </a:p>
@@ -7871,7 +8019,7 @@
           <a:p>
             <a:fld id="{52B883A0-F701-0F49-9D67-42F97F0F4C65}" type="datetime2">
               <a:rPr lang="en-US" smtClean="0"/>
-              <a:t>Friday, January 27, 2023</a:t>
+              <a:t>Thursday, March 2, 2023</a:t>
             </a:fld>
             <a:endParaRPr lang="en-US"/>
           </a:p>
@@ -7993,7 +8141,7 @@
           <a:p>
             <a:fld id="{E6923127-F9F8-8B4E-9CEB-95BF7FFEA85F}" type="datetime2">
               <a:rPr lang="en-US" smtClean="0"/>
-              <a:t>Friday, January 27, 2023</a:t>
+              <a:t>Thursday, March 2, 2023</a:t>
             </a:fld>
             <a:endParaRPr lang="en-US"/>
           </a:p>
@@ -8316,7 +8464,7 @@
           <a:p>
             <a:fld id="{24AFEB34-53E9-8F42-9ED2-04274EE70207}" type="datetime2">
               <a:rPr lang="en-US" smtClean="0"/>
-              <a:t>Friday, January 27, 2023</a:t>
+              <a:t>Thursday, March 2, 2023</a:t>
             </a:fld>
             <a:endParaRPr lang="en-US"/>
           </a:p>
@@ -8604,7 +8752,7 @@
           <a:p>
             <a:fld id="{78864A2C-3282-224A-8A3B-B1B48911DC1D}" type="datetime2">
               <a:rPr lang="en-US" smtClean="0"/>
-              <a:t>Friday, January 27, 2023</a:t>
+              <a:t>Thursday, March 2, 2023</a:t>
             </a:fld>
             <a:endParaRPr lang="en-US"/>
           </a:p>
@@ -8895,7 +9043,7 @@
           <a:p>
             <a:fld id="{6A398F71-50EE-C442-9A03-D3A19758747B}" type="datetime2">
               <a:rPr lang="en-US" smtClean="0"/>
-              <a:t>Friday, January 27, 2023</a:t>
+              <a:t>Thursday, March 2, 2023</a:t>
             </a:fld>
             <a:endParaRPr lang="en-US" dirty="0"/>
           </a:p>
@@ -14158,6 +14306,595 @@
 </file>
 
 <file path=ppt/slides/slide15.xml><?xml version="1.0" encoding="utf-8"?>
+<p:sld xmlns:a="http://schemas.openxmlformats.org/drawingml/2006/main" xmlns:r="http://schemas.openxmlformats.org/officeDocument/2006/relationships" xmlns:p="http://schemas.openxmlformats.org/presentationml/2006/main" showMasterSp="0">
+  <p:cSld>
+    <p:spTree>
+      <p:nvGrpSpPr>
+        <p:cNvPr id="1" name=""/>
+        <p:cNvGrpSpPr/>
+        <p:nvPr/>
+      </p:nvGrpSpPr>
+      <p:grpSpPr>
+        <a:xfrm>
+          <a:off x="0" y="0"/>
+          <a:ext cx="0" cy="0"/>
+          <a:chOff x="0" y="0"/>
+          <a:chExt cx="0" cy="0"/>
+        </a:xfrm>
+      </p:grpSpPr>
+      <p:sp>
+        <p:nvSpPr>
+          <p:cNvPr id="2" name="Title 1">
+            <a:extLst>
+              <a:ext uri="{FF2B5EF4-FFF2-40B4-BE49-F238E27FC236}">
+                <a16:creationId xmlns:a16="http://schemas.microsoft.com/office/drawing/2014/main" id="{062E6DC6-9E0D-BF41-BD13-30B6C7CD2269}"/>
+              </a:ext>
+            </a:extLst>
+          </p:cNvPr>
+          <p:cNvSpPr>
+            <a:spLocks noGrp="1"/>
+          </p:cNvSpPr>
+          <p:nvPr>
+            <p:ph type="title"/>
+          </p:nvPr>
+        </p:nvSpPr>
+        <p:spPr/>
+        <p:txBody>
+          <a:bodyPr/>
+          <a:lstStyle/>
+          <a:p>
+            <a:r>
+              <a:rPr lang="en-US" dirty="0">
+                <a:solidFill>
+                  <a:schemeClr val="bg1"/>
+                </a:solidFill>
+              </a:rPr>
+              <a:t>Feedback </a:t>
+            </a:r>
+          </a:p>
+        </p:txBody>
+      </p:sp>
+      <p:sp>
+        <p:nvSpPr>
+          <p:cNvPr id="21" name="Content Placeholder 2">
+            <a:extLst>
+              <a:ext uri="{FF2B5EF4-FFF2-40B4-BE49-F238E27FC236}">
+                <a16:creationId xmlns:a16="http://schemas.microsoft.com/office/drawing/2014/main" id="{A9E25E25-E0B7-A94D-B740-F1553DF6E446}"/>
+              </a:ext>
+            </a:extLst>
+          </p:cNvPr>
+          <p:cNvSpPr>
+            <a:spLocks noGrp="1"/>
+          </p:cNvSpPr>
+          <p:nvPr>
+            <p:ph idx="1"/>
+          </p:nvPr>
+        </p:nvSpPr>
+        <p:spPr>
+          <a:xfrm>
+            <a:off x="569516" y="1441893"/>
+            <a:ext cx="11052967" cy="3864074"/>
+          </a:xfrm>
+        </p:spPr>
+        <p:txBody>
+          <a:bodyPr>
+            <a:normAutofit fontScale="85000" lnSpcReduction="20000"/>
+          </a:bodyPr>
+          <a:lstStyle/>
+          <a:p>
+            <a:r>
+              <a:rPr lang="en-US" b="1" dirty="0">
+                <a:solidFill>
+                  <a:schemeClr val="bg1"/>
+                </a:solidFill>
+              </a:rPr>
+              <a:t> </a:t>
+            </a:r>
+            <a:r>
+              <a:rPr lang="en-US" b="1" dirty="0" err="1">
+                <a:solidFill>
+                  <a:schemeClr val="bg1"/>
+                </a:solidFill>
+              </a:rPr>
+              <a:t>tp_term_list</a:t>
+            </a:r>
+            <a:r>
+              <a:rPr lang="en-US" b="1" dirty="0">
+                <a:solidFill>
+                  <a:schemeClr val="bg1"/>
+                </a:solidFill>
+              </a:rPr>
+              <a:t> </a:t>
+            </a:r>
+            <a:r>
+              <a:rPr lang="en-US" dirty="0">
+                <a:solidFill>
+                  <a:schemeClr val="bg1"/>
+                </a:solidFill>
+              </a:rPr>
+              <a:t>= ["Endoplasmic Reticulum", "Secreted", "secreted", "Endoplasmic reticulum", "Rough endoplasmic reticulum", "endoplasmic reticulum"], </a:t>
+            </a:r>
+            <a:r>
+              <a:rPr lang="en-US" b="1" dirty="0">
+                <a:solidFill>
+                  <a:schemeClr val="bg1"/>
+                </a:solidFill>
+              </a:rPr>
+              <a:t>removed:</a:t>
+            </a:r>
+            <a:r>
+              <a:rPr lang="en-US" dirty="0">
+                <a:solidFill>
+                  <a:schemeClr val="bg1"/>
+                </a:solidFill>
+              </a:rPr>
+              <a:t> "Golgi", "Extracellular space", "extracellular space", </a:t>
+            </a:r>
+            <a:endParaRPr kumimoji="0" lang="en-US" sz="2000" b="0" i="0" u="none" strike="noStrike" kern="1200" cap="none" spc="20" normalizeH="0" baseline="0" noProof="0" dirty="0">
+              <a:ln>
+                <a:noFill/>
+              </a:ln>
+              <a:solidFill>
+                <a:schemeClr val="bg1"/>
+              </a:solidFill>
+              <a:effectLst/>
+              <a:uLnTx/>
+              <a:uFillTx/>
+              <a:latin typeface="Avenir Next LT Pro"/>
+              <a:ea typeface="+mn-ea"/>
+              <a:cs typeface="+mn-cs"/>
+            </a:endParaRPr>
+          </a:p>
+          <a:p>
+            <a:r>
+              <a:rPr kumimoji="0" lang="en-US" sz="2000" b="0" i="0" u="none" strike="noStrike" kern="1200" cap="none" spc="20" normalizeH="0" baseline="0" noProof="0" dirty="0">
+                <a:ln>
+                  <a:noFill/>
+                </a:ln>
+                <a:solidFill>
+                  <a:schemeClr val="bg1"/>
+                </a:solidFill>
+                <a:effectLst/>
+                <a:uLnTx/>
+                <a:uFillTx/>
+                <a:latin typeface="Avenir Next LT Pro"/>
+                <a:ea typeface="+mn-ea"/>
+                <a:cs typeface="+mn-cs"/>
+              </a:rPr>
+              <a:t> </a:t>
+            </a:r>
+            <a:r>
+              <a:rPr kumimoji="0" lang="en-US" sz="2000" b="1" i="0" u="none" strike="noStrike" kern="1200" cap="none" spc="20" normalizeH="0" baseline="0" noProof="0" dirty="0" err="1">
+                <a:ln>
+                  <a:noFill/>
+                </a:ln>
+                <a:solidFill>
+                  <a:schemeClr val="bg1"/>
+                </a:solidFill>
+                <a:effectLst/>
+                <a:uLnTx/>
+                <a:uFillTx/>
+                <a:latin typeface="Avenir Next LT Pro"/>
+                <a:ea typeface="+mn-ea"/>
+                <a:cs typeface="+mn-cs"/>
+              </a:rPr>
+              <a:t>fp_term_list</a:t>
+            </a:r>
+            <a:r>
+              <a:rPr kumimoji="0" lang="en-US" sz="2000" b="0" i="0" u="none" strike="noStrike" kern="1200" cap="none" spc="20" normalizeH="0" baseline="0" noProof="0" dirty="0">
+                <a:ln>
+                  <a:noFill/>
+                </a:ln>
+                <a:solidFill>
+                  <a:schemeClr val="bg1"/>
+                </a:solidFill>
+                <a:effectLst/>
+                <a:uLnTx/>
+                <a:uFillTx/>
+                <a:latin typeface="Avenir Next LT Pro"/>
+                <a:ea typeface="+mn-ea"/>
+                <a:cs typeface="+mn-cs"/>
+              </a:rPr>
+              <a:t> = ["Nucleus", "nucleus", "Mitochondrion", "mitochondrion"], </a:t>
+            </a:r>
+            <a:r>
+              <a:rPr kumimoji="0" lang="en-US" sz="2000" b="1" i="0" u="none" strike="noStrike" kern="1200" cap="none" spc="20" normalizeH="0" baseline="0" noProof="0" dirty="0">
+                <a:ln>
+                  <a:noFill/>
+                </a:ln>
+                <a:solidFill>
+                  <a:schemeClr val="bg1"/>
+                </a:solidFill>
+                <a:effectLst/>
+                <a:uLnTx/>
+                <a:uFillTx/>
+                <a:latin typeface="Avenir Next LT Pro"/>
+                <a:ea typeface="+mn-ea"/>
+                <a:cs typeface="+mn-cs"/>
+              </a:rPr>
+              <a:t>removed: </a:t>
+            </a:r>
+            <a:r>
+              <a:rPr kumimoji="0" lang="en-US" sz="2000" b="0" i="0" u="none" strike="noStrike" kern="1200" cap="none" spc="20" normalizeH="0" baseline="0" noProof="0" dirty="0">
+                <a:ln>
+                  <a:noFill/>
+                </a:ln>
+                <a:solidFill>
+                  <a:schemeClr val="bg1"/>
+                </a:solidFill>
+                <a:effectLst/>
+                <a:uLnTx/>
+                <a:uFillTx/>
+                <a:latin typeface="Avenir Next LT Pro"/>
+                <a:ea typeface="+mn-ea"/>
+                <a:cs typeface="+mn-cs"/>
+              </a:rPr>
+              <a:t>'cytoskeleton' "Cytoskeleton",</a:t>
+            </a:r>
+          </a:p>
+          <a:p>
+            <a:pPr>
+              <a:buClr>
+                <a:srgbClr val="7BAF34"/>
+              </a:buClr>
+              <a:defRPr/>
+            </a:pPr>
+            <a:r>
+              <a:rPr lang="en-US" b="1" dirty="0">
+                <a:solidFill>
+                  <a:schemeClr val="bg1"/>
+                </a:solidFill>
+              </a:rPr>
+              <a:t>FP: </a:t>
+            </a:r>
+            <a:r>
+              <a:rPr lang="en-US" dirty="0">
+                <a:solidFill>
+                  <a:schemeClr val="bg1"/>
+                </a:solidFill>
+              </a:rPr>
+              <a:t>5344 </a:t>
+            </a:r>
+          </a:p>
+          <a:p>
+            <a:pPr>
+              <a:buClr>
+                <a:srgbClr val="7BAF34"/>
+              </a:buClr>
+              <a:defRPr/>
+            </a:pPr>
+            <a:r>
+              <a:rPr lang="en-US" b="1" dirty="0">
+                <a:solidFill>
+                  <a:schemeClr val="bg1"/>
+                </a:solidFill>
+              </a:rPr>
+              <a:t>TP:</a:t>
+            </a:r>
+            <a:r>
+              <a:rPr lang="en-US" dirty="0">
+                <a:solidFill>
+                  <a:schemeClr val="bg1"/>
+                </a:solidFill>
+              </a:rPr>
+              <a:t> 2808</a:t>
+            </a:r>
+          </a:p>
+          <a:p>
+            <a:pPr>
+              <a:buClr>
+                <a:srgbClr val="7BAF34"/>
+              </a:buClr>
+              <a:defRPr/>
+            </a:pPr>
+            <a:endParaRPr kumimoji="0" lang="en-US" sz="2000" b="0" i="0" u="none" strike="noStrike" kern="1200" cap="none" spc="20" normalizeH="0" baseline="0" noProof="0" dirty="0">
+              <a:ln>
+                <a:noFill/>
+              </a:ln>
+              <a:solidFill>
+                <a:schemeClr val="bg1"/>
+              </a:solidFill>
+              <a:effectLst/>
+              <a:uLnTx/>
+              <a:uFillTx/>
+              <a:latin typeface="Avenir Next LT Pro"/>
+              <a:ea typeface="+mn-ea"/>
+              <a:cs typeface="+mn-cs"/>
+            </a:endParaRPr>
+          </a:p>
+          <a:p>
+            <a:pPr>
+              <a:buClr>
+                <a:srgbClr val="7BAF34"/>
+              </a:buClr>
+              <a:defRPr/>
+            </a:pPr>
+            <a:r>
+              <a:rPr kumimoji="0" lang="en-US" sz="2000" b="0" i="0" u="none" strike="noStrike" kern="1200" cap="none" spc="20" normalizeH="0" baseline="0" noProof="0" dirty="0">
+                <a:ln>
+                  <a:noFill/>
+                </a:ln>
+                <a:solidFill>
+                  <a:schemeClr val="bg1"/>
+                </a:solidFill>
+                <a:effectLst/>
+                <a:uLnTx/>
+                <a:uFillTx/>
+                <a:latin typeface="Avenir Next LT Pro"/>
+                <a:ea typeface="+mn-ea"/>
+                <a:cs typeface="+mn-cs"/>
+              </a:rPr>
+              <a:t>Run analysis with new FP and TP lists </a:t>
+            </a:r>
+          </a:p>
+          <a:p>
+            <a:pPr>
+              <a:buClr>
+                <a:srgbClr val="7BAF34"/>
+              </a:buClr>
+              <a:defRPr/>
+            </a:pPr>
+            <a:r>
+              <a:rPr lang="en-US" dirty="0">
+                <a:solidFill>
+                  <a:schemeClr val="bg1"/>
+                </a:solidFill>
+                <a:latin typeface="Avenir Next LT Pro"/>
+              </a:rPr>
+              <a:t>Add table that was use for volcano plots </a:t>
+            </a:r>
+          </a:p>
+          <a:p>
+            <a:pPr>
+              <a:buClr>
+                <a:srgbClr val="7BAF34"/>
+              </a:buClr>
+              <a:defRPr/>
+            </a:pPr>
+            <a:r>
+              <a:rPr kumimoji="0" lang="en-US" sz="2000" b="0" i="0" u="none" strike="noStrike" kern="1200" cap="none" spc="20" normalizeH="0" baseline="0" noProof="0" dirty="0">
+                <a:ln>
+                  <a:noFill/>
+                </a:ln>
+                <a:solidFill>
+                  <a:schemeClr val="bg1"/>
+                </a:solidFill>
+                <a:effectLst/>
+                <a:uLnTx/>
+                <a:uFillTx/>
+                <a:latin typeface="Avenir Next LT Pro"/>
+                <a:ea typeface="+mn-ea"/>
+                <a:cs typeface="+mn-cs"/>
+              </a:rPr>
+              <a:t>improve folder structure</a:t>
+            </a:r>
+          </a:p>
+          <a:p>
+            <a:pPr lvl="1">
+              <a:spcBef>
+                <a:spcPts val="1000"/>
+              </a:spcBef>
+              <a:buClr>
+                <a:srgbClr val="7BAF34"/>
+              </a:buClr>
+              <a:defRPr/>
+            </a:pPr>
+            <a:endParaRPr kumimoji="0" lang="en-US" b="0" i="0" u="none" strike="noStrike" kern="1200" cap="none" spc="20" normalizeH="0" baseline="0" noProof="0" dirty="0">
+              <a:ln>
+                <a:noFill/>
+              </a:ln>
+              <a:solidFill>
+                <a:schemeClr val="bg1"/>
+              </a:solidFill>
+              <a:effectLst/>
+              <a:uLnTx/>
+              <a:uFillTx/>
+              <a:latin typeface="Avenir Next LT Pro"/>
+              <a:ea typeface="+mn-ea"/>
+              <a:cs typeface="+mn-cs"/>
+            </a:endParaRPr>
+          </a:p>
+          <a:p>
+            <a:pPr marL="228600" marR="0" lvl="0" indent="-228600" algn="l" defTabSz="914400" rtl="0" eaLnBrk="1" fontAlgn="auto" latinLnBrk="0" hangingPunct="1">
+              <a:lnSpc>
+                <a:spcPct val="120000"/>
+              </a:lnSpc>
+              <a:spcBef>
+                <a:spcPts val="1000"/>
+              </a:spcBef>
+              <a:spcAft>
+                <a:spcPts val="0"/>
+              </a:spcAft>
+              <a:buClr>
+                <a:srgbClr val="7BAF34"/>
+              </a:buClr>
+              <a:buSzTx/>
+              <a:buFont typeface="The Hand Extrablack" panose="03070A02030502020204" pitchFamily="66" charset="0"/>
+              <a:buChar char="•"/>
+              <a:tabLst/>
+              <a:defRPr/>
+            </a:pPr>
+            <a:endParaRPr lang="en-US" dirty="0">
+              <a:solidFill>
+                <a:schemeClr val="bg1"/>
+              </a:solidFill>
+              <a:latin typeface="Avenir Next LT Pro"/>
+            </a:endParaRPr>
+          </a:p>
+          <a:p>
+            <a:pPr marL="0" marR="0" lvl="0" indent="0" algn="l" defTabSz="914400" rtl="0" eaLnBrk="1" fontAlgn="auto" latinLnBrk="0" hangingPunct="1">
+              <a:lnSpc>
+                <a:spcPct val="120000"/>
+              </a:lnSpc>
+              <a:spcBef>
+                <a:spcPts val="1000"/>
+              </a:spcBef>
+              <a:spcAft>
+                <a:spcPts val="0"/>
+              </a:spcAft>
+              <a:buClr>
+                <a:srgbClr val="7BAF34"/>
+              </a:buClr>
+              <a:buSzTx/>
+              <a:buNone/>
+              <a:tabLst/>
+              <a:defRPr/>
+            </a:pPr>
+            <a:endParaRPr kumimoji="0" lang="en-US" sz="2000" b="0" i="0" u="none" strike="noStrike" kern="1200" cap="none" spc="20" normalizeH="0" baseline="0" noProof="0" dirty="0">
+              <a:ln>
+                <a:noFill/>
+              </a:ln>
+              <a:solidFill>
+                <a:srgbClr val="000000"/>
+              </a:solidFill>
+              <a:effectLst/>
+              <a:uLnTx/>
+              <a:uFillTx/>
+              <a:latin typeface="Avenir Next LT Pro"/>
+              <a:ea typeface="+mn-ea"/>
+              <a:cs typeface="+mn-cs"/>
+            </a:endParaRPr>
+          </a:p>
+          <a:p>
+            <a:pPr marL="228600" marR="0" lvl="0" indent="-228600" algn="l" defTabSz="914400" rtl="0" eaLnBrk="1" fontAlgn="auto" latinLnBrk="0" hangingPunct="1">
+              <a:lnSpc>
+                <a:spcPct val="120000"/>
+              </a:lnSpc>
+              <a:spcBef>
+                <a:spcPts val="1000"/>
+              </a:spcBef>
+              <a:spcAft>
+                <a:spcPts val="0"/>
+              </a:spcAft>
+              <a:buClr>
+                <a:srgbClr val="7BAF34"/>
+              </a:buClr>
+              <a:buSzTx/>
+              <a:buFont typeface="The Hand Extrablack" panose="03070A02030502020204" pitchFamily="66" charset="0"/>
+              <a:buChar char="•"/>
+              <a:tabLst/>
+              <a:defRPr/>
+            </a:pPr>
+            <a:endParaRPr kumimoji="0" lang="en-US" sz="2000" b="0" i="0" u="none" strike="noStrike" kern="1200" cap="none" spc="20" normalizeH="0" baseline="0" noProof="0" dirty="0">
+              <a:ln>
+                <a:noFill/>
+              </a:ln>
+              <a:solidFill>
+                <a:srgbClr val="000000"/>
+              </a:solidFill>
+              <a:effectLst/>
+              <a:uLnTx/>
+              <a:uFillTx/>
+              <a:latin typeface="Avenir Next LT Pro"/>
+              <a:ea typeface="+mn-ea"/>
+              <a:cs typeface="+mn-cs"/>
+            </a:endParaRPr>
+          </a:p>
+        </p:txBody>
+      </p:sp>
+      <p:sp>
+        <p:nvSpPr>
+          <p:cNvPr id="3" name="Slide Number Placeholder 2">
+            <a:extLst>
+              <a:ext uri="{FF2B5EF4-FFF2-40B4-BE49-F238E27FC236}">
+                <a16:creationId xmlns:a16="http://schemas.microsoft.com/office/drawing/2014/main" id="{1D6F3C52-A33C-B54E-85E5-94566199A529}"/>
+              </a:ext>
+            </a:extLst>
+          </p:cNvPr>
+          <p:cNvSpPr>
+            <a:spLocks noGrp="1"/>
+          </p:cNvSpPr>
+          <p:nvPr>
+            <p:ph type="sldNum" sz="quarter" idx="12"/>
+          </p:nvPr>
+        </p:nvSpPr>
+        <p:spPr/>
+        <p:txBody>
+          <a:bodyPr/>
+          <a:lstStyle/>
+          <a:p>
+            <a:pPr marL="0" marR="0" lvl="0" indent="0" algn="r" defTabSz="914400" rtl="0" eaLnBrk="1" fontAlgn="auto" latinLnBrk="0" hangingPunct="1">
+              <a:lnSpc>
+                <a:spcPct val="120000"/>
+              </a:lnSpc>
+              <a:spcBef>
+                <a:spcPts val="0"/>
+              </a:spcBef>
+              <a:spcAft>
+                <a:spcPts val="0"/>
+              </a:spcAft>
+              <a:buClrTx/>
+              <a:buSzTx/>
+              <a:buFontTx/>
+              <a:buNone/>
+              <a:tabLst/>
+              <a:defRPr/>
+            </a:pPr>
+            <a:fld id="{1621B6DD-29C1-4FEA-923F-71EA1347694C}" type="slidenum">
+              <a:rPr kumimoji="0" lang="en-US" sz="1200" b="0" i="0" u="none" strike="noStrike" kern="1200" cap="none" spc="20" normalizeH="0" baseline="0" noProof="0" smtClean="0">
+                <a:ln>
+                  <a:noFill/>
+                </a:ln>
+                <a:solidFill>
+                  <a:srgbClr val="000000"/>
+                </a:solidFill>
+                <a:effectLst/>
+                <a:uLnTx/>
+                <a:uFillTx/>
+                <a:latin typeface="Avenir Next LT Pro"/>
+                <a:ea typeface="+mn-ea"/>
+                <a:cs typeface="+mn-cs"/>
+              </a:rPr>
+              <a:pPr marL="0" marR="0" lvl="0" indent="0" algn="r" defTabSz="914400" rtl="0" eaLnBrk="1" fontAlgn="auto" latinLnBrk="0" hangingPunct="1">
+                <a:lnSpc>
+                  <a:spcPct val="120000"/>
+                </a:lnSpc>
+                <a:spcBef>
+                  <a:spcPts val="0"/>
+                </a:spcBef>
+                <a:spcAft>
+                  <a:spcPts val="0"/>
+                </a:spcAft>
+                <a:buClrTx/>
+                <a:buSzTx/>
+                <a:buFontTx/>
+                <a:buNone/>
+                <a:tabLst/>
+                <a:defRPr/>
+              </a:pPr>
+              <a:t>14</a:t>
+            </a:fld>
+            <a:endParaRPr kumimoji="0" lang="en-US" sz="1200" b="0" i="0" u="none" strike="noStrike" kern="1200" cap="none" spc="20" normalizeH="0" baseline="0" noProof="0">
+              <a:ln>
+                <a:noFill/>
+              </a:ln>
+              <a:solidFill>
+                <a:srgbClr val="000000"/>
+              </a:solidFill>
+              <a:effectLst/>
+              <a:uLnTx/>
+              <a:uFillTx/>
+              <a:latin typeface="Avenir Next LT Pro"/>
+              <a:ea typeface="+mn-ea"/>
+              <a:cs typeface="+mn-cs"/>
+            </a:endParaRPr>
+          </a:p>
+        </p:txBody>
+      </p:sp>
+    </p:spTree>
+    <p:extLst>
+      <p:ext uri="{BB962C8B-B14F-4D97-AF65-F5344CB8AC3E}">
+        <p14:creationId xmlns:p14="http://schemas.microsoft.com/office/powerpoint/2010/main" val="1409991125"/>
+      </p:ext>
+    </p:extLst>
+  </p:cSld>
+  <p:clrMapOvr>
+    <a:masterClrMapping/>
+  </p:clrMapOvr>
+</p:sld>
+</file>
+
+<file path=ppt/slides/slide16.xml><?xml version="1.0" encoding="utf-8"?>
 <p:sld xmlns:a="http://schemas.openxmlformats.org/drawingml/2006/main" xmlns:r="http://schemas.openxmlformats.org/officeDocument/2006/relationships" xmlns:p="http://schemas.openxmlformats.org/presentationml/2006/main">
   <p:cSld>
     <p:spTree>
@@ -14225,7 +14962,7 @@
           <a:p>
             <a:fld id="{1621B6DD-29C1-4FEA-923F-71EA1347694C}" type="slidenum">
               <a:rPr lang="en-US" smtClean="0"/>
-              <a:t>14</a:t>
+              <a:t>15</a:t>
             </a:fld>
             <a:endParaRPr lang="en-US"/>
           </a:p>

</xml_diff>